<commit_message>
Withdraw the invalid wing-scenario results and publish the corrected ones
The first wing result (-18.7% / -6.6% risk for objective C) came from plans
whose stations were tied to the network by a single shared target, a gauge
freedom the covariance solve reports as zero variance. With rigid
connectivity enforced the four objectives are within 1.6% of each other.
Docs, README, figures and the workflow deck are corrected.

Co-Authored-By: Claude Sonnet 5.5 <noreply@anthropic.com>
Claude-Session: https://claude.ai/code/session_01CgZ1aeWKzpejhgkV8yeDsd
</commit_message>
<xml_diff>
--- a/docs/testbed_workflow.pptx
+++ b/docs/testbed_workflow.pptx
@@ -124,13 +124,13 @@
   <p:extLst>
     <p:ext uri="{521415D9-36F7-43E2-AB2F-B90AF26B5E84}">
       <p14:sectionLst xmlns:p14="http://schemas.microsoft.com/office/powerpoint/2010/main">
-        <p14:section name="Introduction" id="{d2a6009a-01d5-8fc9-43cc-eac6396cc3bf}">
+        <p14:section name="Introduction" id="{36fd1e23-26b5-58b5-7934-af16f05e5f9f}">
           <p14:sldIdLst>
             <p14:sldId id="256"/>
             <p14:sldId id="257"/>
           </p14:sldIdLst>
         </p14:section>
-        <p14:section name="Part 1: The physics chain" id="{747c0f7f-ad1c-5574-a543-0fb0e13721b0}">
+        <p14:section name="Part 1: The physics chain" id="{c375403c-a3a3-3f01-6c5c-68a8f2da66de}">
           <p14:sldIdLst>
             <p14:sldId id="258"/>
             <p14:sldId id="259"/>
@@ -140,7 +140,7 @@
             <p14:sldId id="263"/>
           </p14:sldIdLst>
         </p14:section>
-        <p14:section name="Part 2: The headline experiment" id="{b7fccae7-4c39-7741-70a4-daf2c84a0056}">
+        <p14:section name="Part 2: The headline experiment" id="{48ef0341-ceda-fe8b-00e1-ce86418bfc47}">
           <p14:sldIdLst>
             <p14:sldId id="264"/>
             <p14:sldId id="265"/>
@@ -150,14 +150,14 @@
             <p14:sldId id="269"/>
           </p14:sldIdLst>
         </p14:section>
-        <p14:section name="Part 3: From code to figures" id="{36095802-124c-7eef-c121-a1f57e927896}">
+        <p14:section name="Part 3: From code to figures" id="{c7340386-96db-1603-48e2-355517ad2848}">
           <p14:sldIdLst>
             <p14:sldId id="270"/>
             <p14:sldId id="271"/>
             <p14:sldId id="272"/>
           </p14:sldIdLst>
         </p14:section>
-        <p14:section name="Reproduce" id="{bba506a3-5fdb-70b7-c7ae-b6aed95734fd}">
+        <p14:section name="Reproduce" id="{7c8e4697-5e56-f5cd-8189-d5d23f93a99f}">
           <p14:sldIdLst>
             <p14:sldId id="273"/>
           </p14:sldIdLst>
@@ -1006,7 +1006,7 @@
           <a:p>
             <a:r>
               <a:rPr lang="en-US" dirty="0"/>
-              <a:t>The harder scene: a single 30 m wing with four named fittings, four network tie points so stations near one end can still pin their own pose, and a support tower that blocks some sightlines. Grid search is combinatorially out of reach here, so each objective runs the GA. The objectives run in sequence and each later search is seeded with every earlier winner, a standard GA technique. That was adopted only after cross-checking caught two unseeded searches converging to clearly worse plans by their own measure. Without the tower, risk falls monotonically A0 → A1 → B → C, 18.7% overall. With it, A0, A1 and B land on the same plan and only C finds a better one, 6.6% lower risk.</a:t>
+              <a:t>The harder scene: a single 30 m wing with four named fittings, four network tie points so stations near one end can still pin their own pose, and a support tower that blocks some sightlines. Grid search is combinatorially out of reach here, so each objective runs the GA. The objectives run in sequence and each later search is seeded with every earlier winner, a standard GA technique. That was adopted only after cross-checking caught two unseeded searches converging to clearly worse plans by their own measure. Correction: an earlier version of this slide reported 18.7% and 6.6% risk reductions. Those were wrong. The planner accepted stations that shared only one target with the network, which leaves that station free to rotate, and the covariance solve reports such a direction as zero variance. The search learned to exploit it. With rigid connectivity enforced, the four objectives are within 1.6% of each other, which is about the size of the GA's own imprecision. Three stations over 30 m leaves the uncertainty at 13 to 47 micrometres against a 50 micrometre tolerance, so total risk is about 0.8 for every objective.</a:t>
             </a:r>
             <a:endParaRPr lang="en-US" dirty="0"/>
           </a:p>
@@ -1270,7 +1270,7 @@
           <a:p>
             <a:r>
               <a:rPr lang="en-US" dirty="0"/>
-              <a:t>Four layers of checking. First, the test suite: every physical claim gets a test against a reference number where one exists, and every build step has a gate that must pass before the next begins. Second, determinism: the main figures reproduce exactly. Third, the shortcut step 6 relies on, noiseless observations, is pinned to a genuinely noisy solve by its own test. Fourth, GA results are never taken on trust: each objective's winning plan is scored under every other objective's formula. In the wing scenario this caught two searches that had converged to clearly worse plans, which is what led to population seeding.</a:t>
+              <a:t>Four layers of checking. First, the test suite: every physical claim gets a test against a reference number where one exists, and every build step has a gate that must pass before the next begins. Second, determinism: the main figures reproduce exactly. Third, the shortcut step 6 relies on, noiseless observations, is pinned to a genuinely noisy solve by its own test. Fourth, GA results are never taken on trust: each objective's winning plan is scored under every other objective's formula. In the wing scenario this caught two searches that had converged to clearly worse plans, which is what led to population seeding. Re-scoring the saved plans with a faster evaluator later exposed a feasibility loophole, stations tied to the network by a single target, and the wing numbers were corrected.</a:t>
             </a:r>
             <a:endParaRPr lang="en-US" dirty="0"/>
           </a:p>
@@ -9144,7 +9144,7 @@
         <p:spPr>
           <a:xfrm>
             <a:off x="548640" y="2880360"/>
-            <a:ext cx="5486400" cy="2991274"/>
+            <a:ext cx="5486400" cy="2933750"/>
           </a:xfrm>
           <a:prstGeom prst="rect">
             <a:avLst/>
@@ -9160,7 +9160,7 @@
         <p:spPr>
           <a:xfrm>
             <a:off x="548640" y="2880360"/>
-            <a:ext cx="5486400" cy="2991274"/>
+            <a:ext cx="5486400" cy="2933750"/>
           </a:xfrm>
           <a:prstGeom prst="rect">
             <a:avLst/>
@@ -9305,7 +9305,7 @@
                   <a:schemeClr val="tx1"/>
                 </a:solidFill>
               </a:rPr>
-              <a:t>every winner is scored under every other objective's formula; two unseeded searches failed this before seeding fixed them</a:t>
+              <a:t>every winner is scored under every other objective's formula. An earlier −18.7% / −6.6% was withdrawn: it came from stations not rigidly tied to the network</a:t>
             </a:r>
             <a:endParaRPr lang="en-US" sz="1200" dirty="0"/>
           </a:p>
@@ -9366,7 +9366,7 @@
                 <a:ea typeface="Cambria" pitchFamily="34" charset="-122"/>
                 <a:cs typeface="Cambria" pitchFamily="34" charset="-120"/>
               </a:rPr>
-              <a:t>−18.7%</a:t>
+              <a:t>−1.6%</a:t>
             </a:r>
             <a:endParaRPr lang="en-US" sz="3200" dirty="0"/>
           </a:p>
@@ -9402,7 +9402,7 @@
                   <a:schemeClr val="tx2"/>
                 </a:solidFill>
               </a:rPr>
-              <a:t>risk, A0 → C, without the tower</a:t>
+              <a:t>risk, A0 → C, without the tower (GA noise ~1%)</a:t>
             </a:r>
             <a:endParaRPr lang="en-US" sz="1200" dirty="0"/>
           </a:p>
@@ -9463,7 +9463,7 @@
                 <a:ea typeface="Cambria" pitchFamily="34" charset="-122"/>
                 <a:cs typeface="Cambria" pitchFamily="34" charset="-120"/>
               </a:rPr>
-              <a:t>−6.6%</a:t>
+              <a:t>−0.7%</a:t>
             </a:r>
             <a:endParaRPr lang="en-US" sz="3200" dirty="0"/>
           </a:p>
@@ -9499,7 +9499,7 @@
                   <a:schemeClr val="tx2"/>
                 </a:solidFill>
               </a:rPr>
-              <a:t>risk, A0 → C, with the tower</a:t>
+              <a:t>risk, A0 → C, with the tower (GA noise ~1%)</a:t>
             </a:r>
             <a:endParaRPr lang="en-US" sz="1200" dirty="0"/>
           </a:p>
@@ -11259,7 +11259,7 @@
                 <a:ea typeface="Cambria" pitchFamily="34" charset="-122"/>
                 <a:cs typeface="Cambria" pitchFamily="34" charset="-120"/>
               </a:rPr>
-              <a:t>129</a:t>
+              <a:t>174</a:t>
             </a:r>
             <a:endParaRPr lang="en-US" sz="5400" dirty="0"/>
           </a:p>
@@ -11730,7 +11730,7 @@
                   <a:schemeClr val="tx2"/>
                 </a:solidFill>
               </a:rPr>
-              <a:t>Each of 4 winning plans scored under all 4 objectives' formulas; this caught two wrong searches.</a:t>
+              <a:t>Each of 4 winning plans scored under all 4 objectives' formulas. This caught two wrong searches, and re-scoring later exposed an invalid-network loophole.</a:t>
             </a:r>
             <a:endParaRPr lang="en-US" sz="1400" dirty="0"/>
           </a:p>
@@ -11959,7 +11959,7 @@
                 <a:ea typeface="Courier New" pitchFamily="34" charset="-122"/>
                 <a:cs typeface="Courier New" pitchFamily="34" charset="-120"/>
               </a:rPr>
-              <a:t>   # 129 tests, about a minute</a:t>
+              <a:t>   # 174 tests, about three minutes</a:t>
             </a:r>
             <a:endParaRPr lang="en-US" sz="1500" dirty="0"/>
           </a:p>

</xml_diff>